<commit_message>
Fix Arabic showing as Chinese when editing text in PowerPoint / Teams
When a text box is clicked (edit mode), PowerPoint for the web / Teams may not use the embedded Amiri font and falls
back by the run's language and the theme. Most Arabic runs were tagged en-US with no East-Asian font slot, so the
fallback came from the theme's Chinese / Japanese / Korean script fonts.

fonts.js now also tags every run that contains Arabic as ar-SA with Amiri (Arabic charset) in the latin, ea and cs
slots, and makes the theme's East-Asian / complex-script fallbacks Amiri with the CJK script fonts removed.
New builds get this automatically; fix-fonts.js applies it in place to decks that are already built (content
untouched). All 494 decks in the repository are repaired.

Co-Authored-By: Claude Opus 5.5 <noreply@anthropic.com>
Claude-Session: https://claude.ai/code/session_01QWUKnGV7MRCnE8883pixoX
</commit_message>
<xml_diff>
--- a/Development_D2/D2-L12_Review_and_Unit_Assessment.pptx
+++ b/Development_D2/D2-L12_Review_and_Unit_Assessment.pptx
@@ -710,7 +710,11 @@
           <a:lstStyle/>
           <a:p>
             <a:r>
-              <a:rPr lang="en-US" dirty="0"/>
+              <a:rPr lang="ar-SA" dirty="0">
+                <a:latin typeface="Amiri" pitchFamily="2" charset="-78"/>
+                <a:ea typeface="Amiri" pitchFamily="2" charset="-78"/>
+                <a:cs typeface="Amiri" pitchFamily="2" charset="-78"/>
+              </a:rPr>
               <a:t>LISTENING TEXT 2 (website). Read twice; two voices if possible.
 SCRIPT: يَبْحَثُ عُمَرُ عَنْ مِعْطَفٍ جَدِيدٍ. يُجَرِّبُ مِعْطَفًا أَزْرَقَ، وَلٰكِنَّهُ ضَيِّقٌ. تُحْضِرُ البَائِعَةُ مَقَاسًا أَكْبَرَ وَتَقُولُ إِنَّ المِعْطَفَ الأَزْرَقَ أَرْخَصُ مِنَ الأَسْوَدِ. مَعَ ذٰلِكَ يَخْتَارُ عُمَرُ الأَسْوَدَ لِأَنَّهُ أَكْثَرُ أَنَاقَةً وَمُنَاسِبٌ لِلْمُنَاسَبَاتِ. يَقُولُ: سَآخُذُهُ، مِنْ فَضْلِكِ.
 Listening total: /12 → ×5/3 = /20 (website profile).</a:t>
@@ -1506,7 +1510,11 @@
           <a:lstStyle/>
           <a:p>
             <a:r>
-              <a:rPr lang="en-US" dirty="0"/>
+              <a:rPr lang="ar-SA" dirty="0">
+                <a:latin typeface="Amiri" pitchFamily="2" charset="-78"/>
+                <a:ea typeface="Amiri" pitchFamily="2" charset="-78"/>
+                <a:cs typeface="Amiri" pitchFamily="2" charset="-78"/>
+              </a:rPr>
               <a:t>WELCOME (1 min) — while students join.
 • Greet each student by name as they arrive: السَّلَامُ عَلَيْكُمْ. Take the register (Pastoral Tracker: attendance 0/1).
 • 2-MINUTE CHECK-IN (SEND training): a private chat to any student who seemed unsettled last lesson — “Are you okay today? 👍 / 👎”.
@@ -1599,7 +1607,11 @@
           <a:lstStyle/>
           <a:p>
             <a:r>
-              <a:rPr lang="en-US" dirty="0"/>
+              <a:rPr lang="ar-SA" dirty="0">
+                <a:latin typeface="Amiri" pitchFamily="2" charset="-78"/>
+                <a:ea typeface="Amiri" pitchFamily="2" charset="-78"/>
+                <a:cs typeface="Amiri" pitchFamily="2" charset="-78"/>
+              </a:rPr>
               <a:t>SPEAKING (website, 10 marks: Communication /5 · Accuracy and range /5).
 Follow-up questions for the conversation part: مَنْ يَدْعَمُكَ؟ · كَيْفَ تَتَفَاهَمَانِ؟ · مَا أَهَمُّ: الرَّاحَةُ أَمِ الأَنَاقَةُ؟ · أَيُّهُمَا تُفَضِّلُ وَلِمَاذَا؟
 ORGANISATION: one-to-one (others finish writing) or trusted pairs with the teacher listening.</a:t>
@@ -2316,7 +2328,11 @@
           <a:lstStyle/>
           <a:p>
             <a:r>
-              <a:rPr lang="en-US" dirty="0"/>
+              <a:rPr lang="ar-SA" dirty="0">
+                <a:latin typeface="Amiri" pitchFamily="2" charset="-78"/>
+                <a:ea typeface="Amiri" pitchFamily="2" charset="-78"/>
+                <a:cs typeface="Amiri" pitchFamily="2" charset="-78"/>
+              </a:rPr>
               <a:t>FLEX — six more website grammar-laboratory questions (comparison, evidence, balanced opinion, superlative, لِأَنَّنَا, developed answer).</a:t>
             </a:r>
             <a:endParaRPr lang="en-US" dirty="0"/>
@@ -2580,7 +2596,11 @@
           <a:lstStyle/>
           <a:p>
             <a:r>
-              <a:rPr lang="en-US" dirty="0"/>
+              <a:rPr lang="ar-SA" dirty="0">
+                <a:latin typeface="Amiri" pitchFamily="2" charset="-78"/>
+                <a:ea typeface="Amiri" pitchFamily="2" charset="-78"/>
+                <a:cs typeface="Amiri" pitchFamily="2" charset="-78"/>
+              </a:rPr>
               <a:t>LISTENING TEXT 1 (website). Students read the questions (30 s). Read the script twice.
 SCRIPT: تَصِفُ هُدَى صَدِيقَتَهَا سَلْمَى. تَقُولُ إِنَّهَا صَبُورَةٌ وَمُتَعَاوِنَةٌ، لِأَنَّهَا تَشْرَحُ العَمَلَ لِلطَّالِبَاتِ الجَدِيدَاتِ. تَرْتَدِي سَلْمَى عَادَةً مَلَابِسَ بَسِيطَةً وَمُحْتَشِمَةً، بَيْنَمَا تُفَضِّلُ هُدَى أَلْوَانًا أَكْثَرَ زَهَاءً. فِي رَأْيِ هُدَى، اخْتِلَافُ الأُسْلُوبِ لَا يَمْنَعُ الصَّدَاقَةَ، لِأَنَّ كُلَّ شَخْصٍ يَخْتَارُ مَا يُنَاسِبُهُ.
 Website note: Q5 “How does the speaker’s style differ?” — Huda prefers brighter colours (أَلْوَانًا أَكْثَرَ زَهَاءً).</a:t>
@@ -3066,6 +3086,7 @@
                   <a:srgbClr val="D4AF37"/>
                 </a:solidFill>
                 <a:latin typeface="Amiri" pitchFamily="2" charset="-78"/>
+                <a:ea typeface="Amiri" pitchFamily="2" charset="-78"/>
                 <a:cs typeface="Amiri" pitchFamily="2" charset="-78"/>
               </a:rPr>
               <a:t>م</a:t>
@@ -3272,6 +3293,7 @@
                   <a:srgbClr val="D4AF37"/>
                 </a:solidFill>
                 <a:latin typeface="Amiri" pitchFamily="2" charset="-78"/>
+                <a:ea typeface="Amiri" pitchFamily="2" charset="-78"/>
                 <a:cs typeface="Amiri" pitchFamily="2" charset="-78"/>
               </a:rPr>
               <a:t>المُرَاجَعَةُ وَالتَّقْيِيمُ</a:t>
@@ -3729,6 +3751,7 @@
                   <a:srgbClr val="D4AF37"/>
                 </a:solidFill>
                 <a:latin typeface="Amiri" pitchFamily="2" charset="-78"/>
+                <a:ea typeface="Amiri" pitchFamily="2" charset="-78"/>
                 <a:cs typeface="Amiri" pitchFamily="2" charset="-78"/>
               </a:rPr>
               <a:t>م</a:t>
@@ -4049,6 +4072,7 @@
                   <a:srgbClr val="8A6D1E"/>
                 </a:solidFill>
                 <a:latin typeface="Amiri" pitchFamily="2" charset="-78"/>
+                <a:ea typeface="Amiri" pitchFamily="2" charset="-78"/>
                 <a:cs typeface="Amiri" pitchFamily="2" charset="-78"/>
               </a:rPr>
               <a:t>الإِجَابَاتُ</a:t>
@@ -5106,6 +5130,7 @@
                   <a:srgbClr val="8A6D1E"/>
                 </a:solidFill>
                 <a:latin typeface="Amiri" pitchFamily="2" charset="-78"/>
+                <a:ea typeface="Amiri" pitchFamily="2" charset="-78"/>
                 <a:cs typeface="Amiri" pitchFamily="2" charset="-78"/>
               </a:rPr>
               <a:t>صَبُورَةٌ وَمُتَعَاوِنَةٌ</a:t>
@@ -7390,6 +7415,7 @@
                   <a:srgbClr val="D4AF37"/>
                 </a:solidFill>
                 <a:latin typeface="Amiri" pitchFamily="2" charset="-78"/>
+                <a:ea typeface="Amiri" pitchFamily="2" charset="-78"/>
                 <a:cs typeface="Amiri" pitchFamily="2" charset="-78"/>
               </a:rPr>
               <a:t>م</a:t>
@@ -7710,6 +7736,7 @@
                   <a:srgbClr val="8A6D1E"/>
                 </a:solidFill>
                 <a:latin typeface="Amiri" pitchFamily="2" charset="-78"/>
+                <a:ea typeface="Amiri" pitchFamily="2" charset="-78"/>
                 <a:cs typeface="Amiri" pitchFamily="2" charset="-78"/>
               </a:rPr>
               <a:t>الاِسْتِمَاعُ (٢)</a:t>
@@ -10635,6 +10662,7 @@
                   <a:srgbClr val="D4AF37"/>
                 </a:solidFill>
                 <a:latin typeface="Amiri" pitchFamily="2" charset="-78"/>
+                <a:ea typeface="Amiri" pitchFamily="2" charset="-78"/>
                 <a:cs typeface="Amiri" pitchFamily="2" charset="-78"/>
               </a:rPr>
               <a:t>م</a:t>
@@ -10955,6 +10983,7 @@
                   <a:srgbClr val="8A6D1E"/>
                 </a:solidFill>
                 <a:latin typeface="Amiri" pitchFamily="2" charset="-78"/>
+                <a:ea typeface="Amiri" pitchFamily="2" charset="-78"/>
                 <a:cs typeface="Amiri" pitchFamily="2" charset="-78"/>
               </a:rPr>
               <a:t>الإِجَابَاتُ</a:t>
@@ -14270,6 +14299,7 @@
                   <a:srgbClr val="D4AF37"/>
                 </a:solidFill>
                 <a:latin typeface="Amiri" pitchFamily="2" charset="-78"/>
+                <a:ea typeface="Amiri" pitchFamily="2" charset="-78"/>
                 <a:cs typeface="Amiri" pitchFamily="2" charset="-78"/>
               </a:rPr>
               <a:t>م</a:t>
@@ -14590,6 +14620,7 @@
                   <a:srgbClr val="8A6D1E"/>
                 </a:solidFill>
                 <a:latin typeface="Amiri" pitchFamily="2" charset="-78"/>
+                <a:ea typeface="Amiri" pitchFamily="2" charset="-78"/>
                 <a:cs typeface="Amiri" pitchFamily="2" charset="-78"/>
               </a:rPr>
               <a:t>نَصُّ القِرَاءَةِ</a:t>
@@ -14703,6 +14734,7 @@
                   <a:srgbClr val="1F2A37"/>
                 </a:solidFill>
                 <a:latin typeface="Amiri" pitchFamily="2" charset="-78"/>
+                <a:ea typeface="Amiri" pitchFamily="2" charset="-78"/>
                 <a:cs typeface="Amiri" pitchFamily="2" charset="-78"/>
               </a:rPr>
               <a:t>سَلْمَى صَدِيقَتِي المُقَرَّبَةُ الَّتِي أَعْرِفُهَا مُنْذُ سِتِّ سَنَوَاتٍ. هِيَ مُتَوَسِّطَةُ القَامَةِ وَلَهَا شَعْرٌ قَصِيرٌ وَمُجَعَّدٌ. تَرْتَدِي عَادَةً مَلَابِسَ أَكْثَرَ رَسْمِيَّةً مِنْ مَلَابِسِي، بَيْنَمَا أُفَضِّلُ أَنَا الأُسْلُوبَ العَمَلِيَّ. سَلْمَى وَدُودَةٌ وَوَاثِقَةٌ؛ فَهِيَ تَتَحَدَّثُ أَمَامَ المَجْمُوعَاتِ دُونَ خَوْفٍ. وَهِيَ أَيْضًا مُتَعَاوِنَةٌ لِأَنَّهَا تُسَاعِدُ الطَّالِبَاتِ الجَدِيدَاتِ. أَثِقُ بِهَا لِأَنَّهَا صَادِقَةٌ وَتَسْتَمِعُ إِلَيَّ. فِي رَأْيِي، المَلَابِسُ قَدْ تُعَبِّرُ عَنِ الذَّوْقِ، وَلٰكِنَّ الشَّخْصِيَّةَ وَالسُّلُوكَ أَهَمُّ مِنَ المَظْهَرِ وَحْدَهُ.</a:t>
@@ -14836,6 +14868,7 @@
                   <a:srgbClr val="D4AF37"/>
                 </a:solidFill>
                 <a:latin typeface="Amiri" pitchFamily="2" charset="-78"/>
+                <a:ea typeface="Amiri" pitchFamily="2" charset="-78"/>
                 <a:cs typeface="Amiri" pitchFamily="2" charset="-78"/>
               </a:rPr>
               <a:t>م</a:t>
@@ -15156,6 +15189,7 @@
                   <a:srgbClr val="8A6D1E"/>
                 </a:solidFill>
                 <a:latin typeface="Amiri" pitchFamily="2" charset="-78"/>
+                <a:ea typeface="Amiri" pitchFamily="2" charset="-78"/>
                 <a:cs typeface="Amiri" pitchFamily="2" charset="-78"/>
               </a:rPr>
               <a:t>القِرَاءَةُ (١–٥)</a:t>
@@ -16656,6 +16690,7 @@
                   <a:srgbClr val="1B3B6F"/>
                 </a:solidFill>
                 <a:latin typeface="Amiri" pitchFamily="2" charset="-78"/>
+                <a:ea typeface="Amiri" pitchFamily="2" charset="-78"/>
                 <a:cs typeface="Amiri" pitchFamily="2" charset="-78"/>
               </a:rPr>
               <a:t>الَّتِي</a:t>
@@ -17669,6 +17704,7 @@
                   <a:srgbClr val="D4AF37"/>
                 </a:solidFill>
                 <a:latin typeface="Amiri" pitchFamily="2" charset="-78"/>
+                <a:ea typeface="Amiri" pitchFamily="2" charset="-78"/>
                 <a:cs typeface="Amiri" pitchFamily="2" charset="-78"/>
               </a:rPr>
               <a:t>م</a:t>
@@ -17989,6 +18025,7 @@
                   <a:srgbClr val="8A6D1E"/>
                 </a:solidFill>
                 <a:latin typeface="Amiri" pitchFamily="2" charset="-78"/>
+                <a:ea typeface="Amiri" pitchFamily="2" charset="-78"/>
                 <a:cs typeface="Amiri" pitchFamily="2" charset="-78"/>
               </a:rPr>
               <a:t>الإِجَابَاتُ</a:t>
@@ -18543,6 +18580,7 @@
                   <a:srgbClr val="8A6D1E"/>
                 </a:solidFill>
                 <a:latin typeface="Amiri" pitchFamily="2" charset="-78"/>
+                <a:ea typeface="Amiri" pitchFamily="2" charset="-78"/>
                 <a:cs typeface="Amiri" pitchFamily="2" charset="-78"/>
               </a:rPr>
               <a:t>صَدِيقَتِي المُقَرَّبَةُ</a:t>
@@ -19710,6 +19748,7 @@
                   <a:srgbClr val="1B3B6F"/>
                 </a:solidFill>
                 <a:latin typeface="Amiri" pitchFamily="2" charset="-78"/>
+                <a:ea typeface="Amiri" pitchFamily="2" charset="-78"/>
                 <a:cs typeface="Amiri" pitchFamily="2" charset="-78"/>
               </a:rPr>
               <a:t>الَّتِي</a:t>
@@ -20853,6 +20892,7 @@
                   <a:srgbClr val="D4AF37"/>
                 </a:solidFill>
                 <a:latin typeface="Amiri" pitchFamily="2" charset="-78"/>
+                <a:ea typeface="Amiri" pitchFamily="2" charset="-78"/>
                 <a:cs typeface="Amiri" pitchFamily="2" charset="-78"/>
               </a:rPr>
               <a:t>م</a:t>
@@ -21173,6 +21213,7 @@
                   <a:srgbClr val="8A6D1E"/>
                 </a:solidFill>
                 <a:latin typeface="Amiri" pitchFamily="2" charset="-78"/>
+                <a:ea typeface="Amiri" pitchFamily="2" charset="-78"/>
                 <a:cs typeface="Amiri" pitchFamily="2" charset="-78"/>
               </a:rPr>
               <a:t>القِرَاءَةُ (٦–١٠)</a:t>
@@ -21885,6 +21926,7 @@
                   <a:srgbClr val="1F2A37"/>
                 </a:solidFill>
                 <a:latin typeface="Amiri" pitchFamily="2" charset="-78"/>
+                <a:ea typeface="Amiri" pitchFamily="2" charset="-78"/>
                 <a:cs typeface="Amiri" pitchFamily="2" charset="-78"/>
               </a:rPr>
               <a:t>لِأَنَّ</a:t>
@@ -21986,6 +22028,7 @@
                   <a:srgbClr val="1F2A37"/>
                 </a:solidFill>
                 <a:latin typeface="Amiri" pitchFamily="2" charset="-78"/>
+                <a:ea typeface="Amiri" pitchFamily="2" charset="-78"/>
                 <a:cs typeface="Amiri" pitchFamily="2" charset="-78"/>
               </a:rPr>
               <a:t>بَيْنَمَا</a:t>
@@ -22087,6 +22130,7 @@
                   <a:srgbClr val="1F2A37"/>
                 </a:solidFill>
                 <a:latin typeface="Amiri" pitchFamily="2" charset="-78"/>
+                <a:ea typeface="Amiri" pitchFamily="2" charset="-78"/>
                 <a:cs typeface="Amiri" pitchFamily="2" charset="-78"/>
               </a:rPr>
               <a:t>ثُمَّ</a:t>
@@ -22323,6 +22367,7 @@
                   <a:srgbClr val="1F2A37"/>
                 </a:solidFill>
                 <a:latin typeface="Amiri" pitchFamily="2" charset="-78"/>
+                <a:ea typeface="Amiri" pitchFamily="2" charset="-78"/>
                 <a:cs typeface="Amiri" pitchFamily="2" charset="-78"/>
               </a:rPr>
               <a:t>أَكْثَرُ رَسْمِيَّةً</a:t>
@@ -22424,6 +22469,7 @@
                   <a:srgbClr val="1F2A37"/>
                 </a:solidFill>
                 <a:latin typeface="Amiri" pitchFamily="2" charset="-78"/>
+                <a:ea typeface="Amiri" pitchFamily="2" charset="-78"/>
                 <a:cs typeface="Amiri" pitchFamily="2" charset="-78"/>
               </a:rPr>
               <a:t>رَسْمِيَّةٌ جِدًّا</a:t>
@@ -22525,6 +22571,7 @@
                   <a:srgbClr val="1F2A37"/>
                 </a:solidFill>
                 <a:latin typeface="Amiri" pitchFamily="2" charset="-78"/>
+                <a:ea typeface="Amiri" pitchFamily="2" charset="-78"/>
                 <a:cs typeface="Amiri" pitchFamily="2" charset="-78"/>
               </a:rPr>
               <a:t>الأَكْثَرُ رَسْمِيَّةً مِنْهَا</a:t>
@@ -23660,6 +23707,7 @@
                   <a:srgbClr val="D4AF37"/>
                 </a:solidFill>
                 <a:latin typeface="Amiri" pitchFamily="2" charset="-78"/>
+                <a:ea typeface="Amiri" pitchFamily="2" charset="-78"/>
                 <a:cs typeface="Amiri" pitchFamily="2" charset="-78"/>
               </a:rPr>
               <a:t>م</a:t>
@@ -23980,6 +24028,7 @@
                   <a:srgbClr val="8A6D1E"/>
                 </a:solidFill>
                 <a:latin typeface="Amiri" pitchFamily="2" charset="-78"/>
+                <a:ea typeface="Amiri" pitchFamily="2" charset="-78"/>
                 <a:cs typeface="Amiri" pitchFamily="2" charset="-78"/>
               </a:rPr>
               <a:t>الإِجَابَاتُ</a:t>
@@ -24757,6 +24806,7 @@
                   <a:srgbClr val="9AA1AB"/>
                 </a:solidFill>
                 <a:latin typeface="Amiri" pitchFamily="2" charset="-78"/>
+                <a:ea typeface="Amiri" pitchFamily="2" charset="-78"/>
                 <a:cs typeface="Amiri" pitchFamily="2" charset="-78"/>
               </a:rPr>
               <a:t>لِأَنَّ</a:t>
@@ -24885,6 +24935,7 @@
                   <a:srgbClr val="1F2A37"/>
                 </a:solidFill>
                 <a:latin typeface="Amiri" pitchFamily="2" charset="-78"/>
+                <a:ea typeface="Amiri" pitchFamily="2" charset="-78"/>
                 <a:cs typeface="Amiri" pitchFamily="2" charset="-78"/>
               </a:rPr>
               <a:t>بَيْنَمَا</a:t>
@@ -24986,6 +25037,7 @@
                   <a:srgbClr val="9AA1AB"/>
                 </a:solidFill>
                 <a:latin typeface="Amiri" pitchFamily="2" charset="-78"/>
+                <a:ea typeface="Amiri" pitchFamily="2" charset="-78"/>
                 <a:cs typeface="Amiri" pitchFamily="2" charset="-78"/>
               </a:rPr>
               <a:t>ثُمَّ</a:t>
@@ -25024,6 +25076,7 @@
                   <a:srgbClr val="8A6D1E"/>
                 </a:solidFill>
                 <a:latin typeface="Amiri" pitchFamily="2" charset="-78"/>
+                <a:ea typeface="Amiri" pitchFamily="2" charset="-78"/>
                 <a:cs typeface="Amiri" pitchFamily="2" charset="-78"/>
               </a:rPr>
               <a:t>بَيْنَمَا</a:t>
@@ -25300,6 +25353,7 @@
                   <a:srgbClr val="1F2A37"/>
                 </a:solidFill>
                 <a:latin typeface="Amiri" pitchFamily="2" charset="-78"/>
+                <a:ea typeface="Amiri" pitchFamily="2" charset="-78"/>
                 <a:cs typeface="Amiri" pitchFamily="2" charset="-78"/>
               </a:rPr>
               <a:t>أَكْثَرُ رَسْمِيَّةً</a:t>
@@ -25401,6 +25455,7 @@
                   <a:srgbClr val="9AA1AB"/>
                 </a:solidFill>
                 <a:latin typeface="Amiri" pitchFamily="2" charset="-78"/>
+                <a:ea typeface="Amiri" pitchFamily="2" charset="-78"/>
                 <a:cs typeface="Amiri" pitchFamily="2" charset="-78"/>
               </a:rPr>
               <a:t>رَسْمِيَّةٌ جِدًّا</a:t>
@@ -25502,6 +25557,7 @@
                   <a:srgbClr val="9AA1AB"/>
                 </a:solidFill>
                 <a:latin typeface="Amiri" pitchFamily="2" charset="-78"/>
+                <a:ea typeface="Amiri" pitchFamily="2" charset="-78"/>
                 <a:cs typeface="Amiri" pitchFamily="2" charset="-78"/>
               </a:rPr>
               <a:t>الأَكْثَرُ رَسْمِيَّةً مِنْهَا</a:t>
@@ -25553,6 +25609,7 @@
                   <a:srgbClr val="8A6D1E"/>
                 </a:solidFill>
                 <a:latin typeface="Amiri" pitchFamily="2" charset="-78"/>
+                <a:ea typeface="Amiri" pitchFamily="2" charset="-78"/>
                 <a:cs typeface="Amiri" pitchFamily="2" charset="-78"/>
               </a:rPr>
               <a:t>أَكْثَرُ رَسْمِيَّةً</a:t>
@@ -26831,6 +26888,7 @@
                   <a:srgbClr val="D4AF37"/>
                 </a:solidFill>
                 <a:latin typeface="Amiri" pitchFamily="2" charset="-78"/>
+                <a:ea typeface="Amiri" pitchFamily="2" charset="-78"/>
                 <a:cs typeface="Amiri" pitchFamily="2" charset="-78"/>
               </a:rPr>
               <a:t>م</a:t>
@@ -27151,6 +27209,7 @@
                   <a:srgbClr val="8A6D1E"/>
                 </a:solidFill>
                 <a:latin typeface="Amiri" pitchFamily="2" charset="-78"/>
+                <a:ea typeface="Amiri" pitchFamily="2" charset="-78"/>
                 <a:cs typeface="Amiri" pitchFamily="2" charset="-78"/>
               </a:rPr>
               <a:t>تَقْيِيمُ الكِتَابَةِ</a:t>
@@ -27355,6 +27414,7 @@
                   <a:srgbClr val="1B3B6F"/>
                 </a:solidFill>
                 <a:latin typeface="Amiri" pitchFamily="2" charset="-78"/>
+                <a:ea typeface="Amiri" pitchFamily="2" charset="-78"/>
                 <a:cs typeface="Amiri" pitchFamily="2" charset="-78"/>
               </a:rPr>
               <a:t>الاِسْمُ: ______</a:t>
@@ -27523,6 +27583,7 @@
                   <a:srgbClr val="1B3B6F"/>
                 </a:solidFill>
                 <a:latin typeface="Amiri" pitchFamily="2" charset="-78"/>
+                <a:ea typeface="Amiri" pitchFamily="2" charset="-78"/>
                 <a:cs typeface="Amiri" pitchFamily="2" charset="-78"/>
               </a:rPr>
               <a:t>صِفَتَانِ شَخْصِيَّتَانِ: ______</a:t>
@@ -27691,6 +27752,7 @@
                   <a:srgbClr val="1B3B6F"/>
                 </a:solidFill>
                 <a:latin typeface="Amiri" pitchFamily="2" charset="-78"/>
+                <a:ea typeface="Amiri" pitchFamily="2" charset="-78"/>
                 <a:cs typeface="Amiri" pitchFamily="2" charset="-78"/>
               </a:rPr>
               <a:t>دَلِيلٌ عَلَى صِفَةٍ: ______</a:t>
@@ -27859,6 +27921,7 @@
                   <a:srgbClr val="1B3B6F"/>
                 </a:solidFill>
                 <a:latin typeface="Amiri" pitchFamily="2" charset="-78"/>
+                <a:ea typeface="Amiri" pitchFamily="2" charset="-78"/>
                 <a:cs typeface="Amiri" pitchFamily="2" charset="-78"/>
               </a:rPr>
               <a:t>وَصْفُ المَظْهَرِ: ______</a:t>
@@ -28027,6 +28090,7 @@
                   <a:srgbClr val="1B3B6F"/>
                 </a:solidFill>
                 <a:latin typeface="Amiri" pitchFamily="2" charset="-78"/>
+                <a:ea typeface="Amiri" pitchFamily="2" charset="-78"/>
                 <a:cs typeface="Amiri" pitchFamily="2" charset="-78"/>
               </a:rPr>
               <a:t>الأُسْلُوبُ فِي المَلَابِسِ: ______</a:t>
@@ -28301,6 +28365,7 @@
                   <a:srgbClr val="D4AF37"/>
                 </a:solidFill>
                 <a:latin typeface="Amiri" pitchFamily="2" charset="-78"/>
+                <a:ea typeface="Amiri" pitchFamily="2" charset="-78"/>
                 <a:cs typeface="Amiri" pitchFamily="2" charset="-78"/>
               </a:rPr>
               <a:t>م</a:t>
@@ -28621,6 +28686,7 @@
                   <a:srgbClr val="8A6D1E"/>
                 </a:solidFill>
                 <a:latin typeface="Amiri" pitchFamily="2" charset="-78"/>
+                <a:ea typeface="Amiri" pitchFamily="2" charset="-78"/>
                 <a:cs typeface="Amiri" pitchFamily="2" charset="-78"/>
               </a:rPr>
               <a:t>نَمُوذَجُ إِجَابَةٍ قَوِيَّةٍ</a:t>
@@ -28724,6 +28790,7 @@
                   <a:srgbClr val="1B3B6F"/>
                 </a:solidFill>
                 <a:latin typeface="Amiri" pitchFamily="2" charset="-78"/>
+                <a:ea typeface="Amiri" pitchFamily="2" charset="-78"/>
                 <a:cs typeface="Amiri" pitchFamily="2" charset="-78"/>
               </a:rPr>
               <a:t>سَأَكْتُبُ عَنْ صَدِيقَتِي سَلْمَى الَّتِي أَعْرِفُهَا مُنْذُ خَمْسِ سَنَوَاتٍ.</a:t>
@@ -28827,6 +28894,7 @@
                   <a:srgbClr val="1B3B6F"/>
                 </a:solidFill>
                 <a:latin typeface="Amiri" pitchFamily="2" charset="-78"/>
+                <a:ea typeface="Amiri" pitchFamily="2" charset="-78"/>
                 <a:cs typeface="Amiri" pitchFamily="2" charset="-78"/>
               </a:rPr>
               <a:t>هِيَ مُتَوَسِّطَةُ القَامَةِ، وَلَهَا شَعْرٌ قَصِيرٌ وَمُجَعَّدٌ، وَتَرْتَدِي عَادَةً مَلَابِسَ بَسِيطَةً وَمُحْتَشِمَةً.</a:t>
@@ -28930,6 +28998,7 @@
                   <a:srgbClr val="1B3B6F"/>
                 </a:solidFill>
                 <a:latin typeface="Amiri" pitchFamily="2" charset="-78"/>
+                <a:ea typeface="Amiri" pitchFamily="2" charset="-78"/>
                 <a:cs typeface="Amiri" pitchFamily="2" charset="-78"/>
               </a:rPr>
               <a:t>سَلْمَى وَدُودَةٌ وَصَادِقَةٌ، وَأَثِقُ بِهَا لِأَنَّهَا تَسْتَمِعُ إِلَيَّ وَتَقُولُ الحَقَّ.</a:t>
@@ -29033,6 +29102,7 @@
                   <a:srgbClr val="1B3B6F"/>
                 </a:solidFill>
                 <a:latin typeface="Amiri" pitchFamily="2" charset="-78"/>
+                <a:ea typeface="Amiri" pitchFamily="2" charset="-78"/>
                 <a:cs typeface="Amiri" pitchFamily="2" charset="-78"/>
               </a:rPr>
               <a:t>أُسْلُوبُهَا أَكْثَرُ عَصْرِيَّةً مِنْ أُسْلُوبِي، بَيْنَمَا أُفَضِّلُ المَلَابِسَ العَمَلِيَّةَ.</a:t>
@@ -29136,6 +29206,7 @@
                   <a:srgbClr val="1B3B6F"/>
                 </a:solidFill>
                 <a:latin typeface="Amiri" pitchFamily="2" charset="-78"/>
+                <a:ea typeface="Amiri" pitchFamily="2" charset="-78"/>
                 <a:cs typeface="Amiri" pitchFamily="2" charset="-78"/>
               </a:rPr>
               <a:t>فِي رَأْيِي، أَفْضَلُ صِفَةٍ فِيهَا هِيَ صِدْقُهَا، لِأَنَّهُ يَجْعَلُ عَلَاقَتَنَا قَوِيَّةً.</a:t>
@@ -29307,6 +29378,7 @@
                   <a:srgbClr val="D4AF37"/>
                 </a:solidFill>
                 <a:latin typeface="Amiri" pitchFamily="2" charset="-78"/>
+                <a:ea typeface="Amiri" pitchFamily="2" charset="-78"/>
                 <a:cs typeface="Amiri" pitchFamily="2" charset="-78"/>
               </a:rPr>
               <a:t>م</a:t>
@@ -29627,6 +29699,7 @@
                   <a:srgbClr val="8A6D1E"/>
                 </a:solidFill>
                 <a:latin typeface="Amiri" pitchFamily="2" charset="-78"/>
+                <a:ea typeface="Amiri" pitchFamily="2" charset="-78"/>
                 <a:cs typeface="Amiri" pitchFamily="2" charset="-78"/>
               </a:rPr>
               <a:t>آدَابُ الصَّفِّ</a:t>
@@ -31158,6 +31231,7 @@
                   <a:srgbClr val="D4AF37"/>
                 </a:solidFill>
                 <a:latin typeface="Amiri" pitchFamily="2" charset="-78"/>
+                <a:ea typeface="Amiri" pitchFamily="2" charset="-78"/>
                 <a:cs typeface="Amiri" pitchFamily="2" charset="-78"/>
               </a:rPr>
               <a:t>م</a:t>
@@ -31478,6 +31552,7 @@
                   <a:srgbClr val="8A6D1E"/>
                 </a:solidFill>
                 <a:latin typeface="Amiri" pitchFamily="2" charset="-78"/>
+                <a:ea typeface="Amiri" pitchFamily="2" charset="-78"/>
                 <a:cs typeface="Amiri" pitchFamily="2" charset="-78"/>
               </a:rPr>
               <a:t>تَقْيِيمُ التَّحَدُّثِ</a:t>
@@ -32598,6 +32673,7 @@
                   <a:srgbClr val="D4AF37"/>
                 </a:solidFill>
                 <a:latin typeface="Amiri" pitchFamily="2" charset="-78"/>
+                <a:ea typeface="Amiri" pitchFamily="2" charset="-78"/>
                 <a:cs typeface="Amiri" pitchFamily="2" charset="-78"/>
               </a:rPr>
               <a:t>م</a:t>
@@ -32918,6 +32994,7 @@
                   <a:srgbClr val="8A6D1E"/>
                 </a:solidFill>
                 <a:latin typeface="Amiri" pitchFamily="2" charset="-78"/>
+                <a:ea typeface="Amiri" pitchFamily="2" charset="-78"/>
                 <a:cs typeface="Amiri" pitchFamily="2" charset="-78"/>
               </a:rPr>
               <a:t>سَجِّلْ دَرَجَتَكَ</a:t>
@@ -34090,6 +34167,7 @@
                   <a:srgbClr val="D4AF37"/>
                 </a:solidFill>
                 <a:latin typeface="Amiri" pitchFamily="2" charset="-78"/>
+                <a:ea typeface="Amiri" pitchFamily="2" charset="-78"/>
                 <a:cs typeface="Amiri" pitchFamily="2" charset="-78"/>
               </a:rPr>
               <a:t>م</a:t>
@@ -34410,6 +34488,7 @@
                   <a:srgbClr val="8A6D1E"/>
                 </a:solidFill>
                 <a:latin typeface="Amiri" pitchFamily="2" charset="-78"/>
+                <a:ea typeface="Amiri" pitchFamily="2" charset="-78"/>
                 <a:cs typeface="Amiri" pitchFamily="2" charset="-78"/>
               </a:rPr>
               <a:t>قَيِّمْ عَمَلَكَ</a:t>
@@ -35567,6 +35646,7 @@
                   <a:srgbClr val="D4AF37"/>
                 </a:solidFill>
                 <a:latin typeface="Amiri" pitchFamily="2" charset="-78"/>
+                <a:ea typeface="Amiri" pitchFamily="2" charset="-78"/>
                 <a:cs typeface="Amiri" pitchFamily="2" charset="-78"/>
               </a:rPr>
               <a:t>م</a:t>
@@ -35887,6 +35967,7 @@
                   <a:srgbClr val="8A6D1E"/>
                 </a:solidFill>
                 <a:latin typeface="Amiri" pitchFamily="2" charset="-78"/>
+                <a:ea typeface="Amiri" pitchFamily="2" charset="-78"/>
                 <a:cs typeface="Amiri" pitchFamily="2" charset="-78"/>
               </a:rPr>
               <a:t>التَّحْضِيرُ لِلدَّرْسِ القَادِمِ</a:t>
@@ -36100,6 +36181,7 @@
                   <a:srgbClr val="1B3B6F"/>
                 </a:solidFill>
                 <a:latin typeface="Amiri" pitchFamily="2" charset="-78"/>
+                <a:ea typeface="Amiri" pitchFamily="2" charset="-78"/>
                 <a:cs typeface="Amiri" pitchFamily="2" charset="-78"/>
               </a:rPr>
               <a:t>مُرَاجَعَةٌ</a:t>
@@ -36189,6 +36271,7 @@
                   <a:srgbClr val="1B3B6F"/>
                 </a:solidFill>
                 <a:latin typeface="Amiri" pitchFamily="2" charset="-78"/>
+                <a:ea typeface="Amiri" pitchFamily="2" charset="-78"/>
                 <a:cs typeface="Amiri" pitchFamily="2" charset="-78"/>
               </a:rPr>
               <a:t>نُقْطَةُ قُوَّةٍ</a:t>
@@ -36268,6 +36351,7 @@
                   <a:srgbClr val="1B3B6F"/>
                 </a:solidFill>
                 <a:latin typeface="Amiri" pitchFamily="2" charset="-78"/>
+                <a:ea typeface="Amiri" pitchFamily="2" charset="-78"/>
                 <a:cs typeface="Amiri" pitchFamily="2" charset="-78"/>
               </a:rPr>
               <a:t>هَدَفٌ</a:t>
@@ -36314,11 +36398,12 @@
               <a:buNone/>
             </a:pPr>
             <a:r>
-              <a:rPr lang="en-US" sz="1000" i="1" dirty="0">
+              <a:rPr lang="ar-SA" sz="1000" i="1" dirty="0">
                 <a:solidFill>
                   <a:srgbClr val="5A6472"/>
                 </a:solidFill>
                 <a:latin typeface="Calibri" pitchFamily="34" charset="0"/>
+                <a:ea typeface="Amiri" pitchFamily="2" charset="-78"/>
                 <a:cs typeface="Amiri" pitchFamily="2" charset="-78"/>
               </a:rPr>
               <a:t>  pl. أَهْدَافٌ</a:t>
@@ -36357,6 +36442,7 @@
                   <a:srgbClr val="1B3B6F"/>
                 </a:solidFill>
                 <a:latin typeface="Amiri" pitchFamily="2" charset="-78"/>
+                <a:ea typeface="Amiri" pitchFamily="2" charset="-78"/>
                 <a:cs typeface="Amiri" pitchFamily="2" charset="-78"/>
               </a:rPr>
               <a:t>أُحَسِّنُ</a:t>
@@ -36403,11 +36489,12 @@
               <a:buNone/>
             </a:pPr>
             <a:r>
-              <a:rPr lang="en-US" sz="1000" i="1" dirty="0">
+              <a:rPr lang="ar-SA" sz="1000" i="1" dirty="0">
                 <a:solidFill>
                   <a:srgbClr val="5A6472"/>
                 </a:solidFill>
                 <a:latin typeface="Calibri" pitchFamily="34" charset="0"/>
+                <a:ea typeface="Amiri" pitchFamily="2" charset="-78"/>
                 <a:cs typeface="Amiri" pitchFamily="2" charset="-78"/>
               </a:rPr>
               <a:t>  he: يُحَسِّنُ</a:t>
@@ -36446,6 +36533,7 @@
                   <a:srgbClr val="1B3B6F"/>
                 </a:solidFill>
                 <a:latin typeface="Amiri" pitchFamily="2" charset="-78"/>
+                <a:ea typeface="Amiri" pitchFamily="2" charset="-78"/>
                 <a:cs typeface="Amiri" pitchFamily="2" charset="-78"/>
               </a:rPr>
               <a:t>أَتَدَرَّبُ</a:t>
@@ -36492,11 +36580,12 @@
               <a:buNone/>
             </a:pPr>
             <a:r>
-              <a:rPr lang="en-US" sz="1000" i="1" dirty="0">
+              <a:rPr lang="ar-SA" sz="1000" i="1" dirty="0">
                 <a:solidFill>
                   <a:srgbClr val="5A6472"/>
                 </a:solidFill>
                 <a:latin typeface="Calibri" pitchFamily="34" charset="0"/>
+                <a:ea typeface="Amiri" pitchFamily="2" charset="-78"/>
                 <a:cs typeface="Amiri" pitchFamily="2" charset="-78"/>
               </a:rPr>
               <a:t>  he: يَتَدَرَّبُ</a:t>
@@ -36611,6 +36700,7 @@
                   <a:srgbClr val="1B3B6F"/>
                 </a:solidFill>
                 <a:latin typeface="Amiri" pitchFamily="2" charset="-78"/>
+                <a:ea typeface="Amiri" pitchFamily="2" charset="-78"/>
                 <a:cs typeface="Amiri" pitchFamily="2" charset="-78"/>
               </a:rPr>
               <a:t>هَدَفِي …</a:t>
@@ -37280,6 +37370,7 @@
                   <a:srgbClr val="FFFFFF"/>
                 </a:solidFill>
                 <a:latin typeface="Amiri" pitchFamily="2" charset="-78"/>
+                <a:ea typeface="Amiri" pitchFamily="2" charset="-78"/>
                 <a:cs typeface="Amiri" pitchFamily="2" charset="-78"/>
               </a:rPr>
               <a:t>أَحْسَنْتُمْ! إِلَى اللِّقَاءِ</a:t>
@@ -37432,6 +37523,7 @@
                   <a:srgbClr val="D4AF37"/>
                 </a:solidFill>
                 <a:latin typeface="Amiri" pitchFamily="2" charset="-78"/>
+                <a:ea typeface="Amiri" pitchFamily="2" charset="-78"/>
                 <a:cs typeface="Amiri" pitchFamily="2" charset="-78"/>
               </a:rPr>
               <a:t>الوَظَائِفُ وَالمِهَنُ</a:t>
@@ -37565,6 +37657,7 @@
                   <a:srgbClr val="D4AF37"/>
                 </a:solidFill>
                 <a:latin typeface="Amiri" pitchFamily="2" charset="-78"/>
+                <a:ea typeface="Amiri" pitchFamily="2" charset="-78"/>
                 <a:cs typeface="Amiri" pitchFamily="2" charset="-78"/>
               </a:rPr>
               <a:t>م</a:t>
@@ -37885,6 +37978,7 @@
                   <a:srgbClr val="8A6D1E"/>
                 </a:solidFill>
                 <a:latin typeface="Amiri" pitchFamily="2" charset="-78"/>
+                <a:ea typeface="Amiri" pitchFamily="2" charset="-78"/>
                 <a:cs typeface="Amiri" pitchFamily="2" charset="-78"/>
               </a:rPr>
               <a:t>خَرِيطَةُ الدَّرْسِ</a:t>
@@ -38199,6 +38293,7 @@
                   <a:srgbClr val="0E7C86"/>
                 </a:solidFill>
                 <a:latin typeface="Amiri" pitchFamily="2" charset="-78"/>
+                <a:ea typeface="Amiri" pitchFamily="2" charset="-78"/>
                 <a:cs typeface="Amiri" pitchFamily="2" charset="-78"/>
               </a:rPr>
               <a:t>المُرَاجَعَةُ</a:t>
@@ -38475,6 +38570,7 @@
                   <a:srgbClr val="1B3B6F"/>
                 </a:solidFill>
                 <a:latin typeface="Amiri" pitchFamily="2" charset="-78"/>
+                <a:ea typeface="Amiri" pitchFamily="2" charset="-78"/>
                 <a:cs typeface="Amiri" pitchFamily="2" charset="-78"/>
               </a:rPr>
               <a:t>خُطَّةُ التَّقْيِيمِ</a:t>
@@ -38751,6 +38847,7 @@
                   <a:srgbClr val="6B4C9A"/>
                 </a:solidFill>
                 <a:latin typeface="Amiri" pitchFamily="2" charset="-78"/>
+                <a:ea typeface="Amiri" pitchFamily="2" charset="-78"/>
                 <a:cs typeface="Amiri" pitchFamily="2" charset="-78"/>
               </a:rPr>
               <a:t>الاِسْتِمَاعُ</a:t>
@@ -39027,6 +39124,7 @@
                   <a:srgbClr val="2F6FB0"/>
                 </a:solidFill>
                 <a:latin typeface="Amiri" pitchFamily="2" charset="-78"/>
+                <a:ea typeface="Amiri" pitchFamily="2" charset="-78"/>
                 <a:cs typeface="Amiri" pitchFamily="2" charset="-78"/>
               </a:rPr>
               <a:t>القِرَاءَةُ</a:t>
@@ -39303,6 +39401,7 @@
                   <a:srgbClr val="1E6B52"/>
                 </a:solidFill>
                 <a:latin typeface="Amiri" pitchFamily="2" charset="-78"/>
+                <a:ea typeface="Amiri" pitchFamily="2" charset="-78"/>
                 <a:cs typeface="Amiri" pitchFamily="2" charset="-78"/>
               </a:rPr>
               <a:t>الكِتَابَةُ وَالتَّحَدُّثُ</a:t>
@@ -39579,6 +39678,7 @@
                   <a:srgbClr val="8A6D1E"/>
                 </a:solidFill>
                 <a:latin typeface="Amiri" pitchFamily="2" charset="-78"/>
+                <a:ea typeface="Amiri" pitchFamily="2" charset="-78"/>
                 <a:cs typeface="Amiri" pitchFamily="2" charset="-78"/>
               </a:rPr>
               <a:t>الهَدَفُ</a:t>
@@ -39855,6 +39955,7 @@
                   <a:srgbClr val="C45A3C"/>
                 </a:solidFill>
                 <a:latin typeface="Amiri" pitchFamily="2" charset="-78"/>
+                <a:ea typeface="Amiri" pitchFamily="2" charset="-78"/>
                 <a:cs typeface="Amiri" pitchFamily="2" charset="-78"/>
               </a:rPr>
               <a:t>اِسْتَعِدَّ</a:t>
@@ -40098,6 +40199,7 @@
                   <a:srgbClr val="D4AF37"/>
                 </a:solidFill>
                 <a:latin typeface="Amiri" pitchFamily="2" charset="-78"/>
+                <a:ea typeface="Amiri" pitchFamily="2" charset="-78"/>
                 <a:cs typeface="Amiri" pitchFamily="2" charset="-78"/>
               </a:rPr>
               <a:t>م</a:t>
@@ -40418,6 +40520,7 @@
                   <a:srgbClr val="8A6D1E"/>
                 </a:solidFill>
                 <a:latin typeface="Amiri" pitchFamily="2" charset="-78"/>
+                <a:ea typeface="Amiri" pitchFamily="2" charset="-78"/>
                 <a:cs typeface="Amiri" pitchFamily="2" charset="-78"/>
               </a:rPr>
               <a:t>اِبْدَأِ الآنَ</a:t>
@@ -40692,6 +40795,7 @@
                   <a:srgbClr val="1F2A37"/>
                 </a:solidFill>
                 <a:latin typeface="Amiri" pitchFamily="2" charset="-78"/>
+                <a:ea typeface="Amiri" pitchFamily="2" charset="-78"/>
                 <a:cs typeface="Amiri" pitchFamily="2" charset="-78"/>
               </a:rPr>
               <a:t>هِيَ وَدُودٌ وَصَادِقٌ.</a:t>
@@ -40793,6 +40897,7 @@
                   <a:srgbClr val="1F2A37"/>
                 </a:solidFill>
                 <a:latin typeface="Amiri" pitchFamily="2" charset="-78"/>
+                <a:ea typeface="Amiri" pitchFamily="2" charset="-78"/>
                 <a:cs typeface="Amiri" pitchFamily="2" charset="-78"/>
               </a:rPr>
               <a:t>هِيَ وَدُودَةٌ وَصَادِقَةٌ.</a:t>
@@ -40894,6 +40999,7 @@
                   <a:srgbClr val="1F2A37"/>
                 </a:solidFill>
                 <a:latin typeface="Amiri" pitchFamily="2" charset="-78"/>
+                <a:ea typeface="Amiri" pitchFamily="2" charset="-78"/>
                 <a:cs typeface="Amiri" pitchFamily="2" charset="-78"/>
               </a:rPr>
               <a:t>هُوَ وَدُودَةٌ.</a:t>
@@ -41130,6 +41236,7 @@
                   <a:srgbClr val="1F2A37"/>
                 </a:solidFill>
                 <a:latin typeface="Amiri" pitchFamily="2" charset="-78"/>
+                <a:ea typeface="Amiri" pitchFamily="2" charset="-78"/>
                 <a:cs typeface="Amiri" pitchFamily="2" charset="-78"/>
               </a:rPr>
               <a:t>أَحْتَرِمُهَا.</a:t>
@@ -41231,6 +41338,7 @@
                   <a:srgbClr val="1F2A37"/>
                 </a:solidFill>
                 <a:latin typeface="Amiri" pitchFamily="2" charset="-78"/>
+                <a:ea typeface="Amiri" pitchFamily="2" charset="-78"/>
                 <a:cs typeface="Amiri" pitchFamily="2" charset="-78"/>
               </a:rPr>
               <a:t>أَحْتَرِمُهُ.</a:t>
@@ -41332,6 +41440,7 @@
                   <a:srgbClr val="1F2A37"/>
                 </a:solidFill>
                 <a:latin typeface="Amiri" pitchFamily="2" charset="-78"/>
+                <a:ea typeface="Amiri" pitchFamily="2" charset="-78"/>
                 <a:cs typeface="Amiri" pitchFamily="2" charset="-78"/>
               </a:rPr>
               <a:t>تَحْتَرِمُنِي.</a:t>
@@ -41568,6 +41677,7 @@
                   <a:srgbClr val="1F2A37"/>
                 </a:solidFill>
                 <a:latin typeface="Amiri" pitchFamily="2" charset="-78"/>
+                <a:ea typeface="Amiri" pitchFamily="2" charset="-78"/>
                 <a:cs typeface="Amiri" pitchFamily="2" charset="-78"/>
               </a:rPr>
               <a:t>هٰذَا السُّتْرَةُ</a:t>
@@ -41669,6 +41779,7 @@
                   <a:srgbClr val="1F2A37"/>
                 </a:solidFill>
                 <a:latin typeface="Amiri" pitchFamily="2" charset="-78"/>
+                <a:ea typeface="Amiri" pitchFamily="2" charset="-78"/>
                 <a:cs typeface="Amiri" pitchFamily="2" charset="-78"/>
               </a:rPr>
               <a:t>هٰذِهِ السُّتْرَةَ</a:t>
@@ -41770,6 +41881,7 @@
                   <a:srgbClr val="1F2A37"/>
                 </a:solidFill>
                 <a:latin typeface="Amiri" pitchFamily="2" charset="-78"/>
+                <a:ea typeface="Amiri" pitchFamily="2" charset="-78"/>
                 <a:cs typeface="Amiri" pitchFamily="2" charset="-78"/>
               </a:rPr>
               <a:t>هٰذِهِ السُّتْرَةُ</a:t>
@@ -42006,6 +42118,7 @@
                   <a:srgbClr val="1F2A37"/>
                 </a:solidFill>
                 <a:latin typeface="Amiri" pitchFamily="2" charset="-78"/>
+                <a:ea typeface="Amiri" pitchFamily="2" charset="-78"/>
                 <a:cs typeface="Amiri" pitchFamily="2" charset="-78"/>
               </a:rPr>
               <a:t>الفَتَاةُ الَّذِي يَرْتَدِي</a:t>
@@ -42107,6 +42220,7 @@
                   <a:srgbClr val="1F2A37"/>
                 </a:solidFill>
                 <a:latin typeface="Amiri" pitchFamily="2" charset="-78"/>
+                <a:ea typeface="Amiri" pitchFamily="2" charset="-78"/>
                 <a:cs typeface="Amiri" pitchFamily="2" charset="-78"/>
               </a:rPr>
               <a:t>الوَلَدُ الَّتِي تَرْتَدِي</a:t>
@@ -42208,6 +42322,7 @@
                   <a:srgbClr val="1F2A37"/>
                 </a:solidFill>
                 <a:latin typeface="Amiri" pitchFamily="2" charset="-78"/>
+                <a:ea typeface="Amiri" pitchFamily="2" charset="-78"/>
                 <a:cs typeface="Amiri" pitchFamily="2" charset="-78"/>
               </a:rPr>
               <a:t>الفَتَاةُ الَّتِي تَرْتَدِي نَظَّارَةً</a:t>
@@ -42444,6 +42559,7 @@
                   <a:srgbClr val="1F2A37"/>
                 </a:solidFill>
                 <a:latin typeface="Amiri" pitchFamily="2" charset="-78"/>
+                <a:ea typeface="Amiri" pitchFamily="2" charset="-78"/>
                 <a:cs typeface="Amiri" pitchFamily="2" charset="-78"/>
               </a:rPr>
               <a:t>عَيْنَاهَا بُنِّيَّتَانِ.</a:t>
@@ -42545,6 +42661,7 @@
                   <a:srgbClr val="1F2A37"/>
                 </a:solidFill>
                 <a:latin typeface="Amiri" pitchFamily="2" charset="-78"/>
+                <a:ea typeface="Amiri" pitchFamily="2" charset="-78"/>
                 <a:cs typeface="Amiri" pitchFamily="2" charset="-78"/>
               </a:rPr>
               <a:t>عَيْنَاهَا بُنِّيَّةٌ.</a:t>
@@ -42646,6 +42763,7 @@
                   <a:srgbClr val="1F2A37"/>
                 </a:solidFill>
                 <a:latin typeface="Amiri" pitchFamily="2" charset="-78"/>
+                <a:ea typeface="Amiri" pitchFamily="2" charset="-78"/>
                 <a:cs typeface="Amiri" pitchFamily="2" charset="-78"/>
               </a:rPr>
               <a:t>عَيْنَاهَا بُنِّيٌّ.</a:t>
@@ -42981,6 +43099,7 @@
                   <a:srgbClr val="D4AF37"/>
                 </a:solidFill>
                 <a:latin typeface="Amiri" pitchFamily="2" charset="-78"/>
+                <a:ea typeface="Amiri" pitchFamily="2" charset="-78"/>
                 <a:cs typeface="Amiri" pitchFamily="2" charset="-78"/>
               </a:rPr>
               <a:t>م</a:t>
@@ -43301,6 +43420,7 @@
                   <a:srgbClr val="8A6D1E"/>
                 </a:solidFill>
                 <a:latin typeface="Amiri" pitchFamily="2" charset="-78"/>
+                <a:ea typeface="Amiri" pitchFamily="2" charset="-78"/>
                 <a:cs typeface="Amiri" pitchFamily="2" charset="-78"/>
               </a:rPr>
               <a:t>الإِجَابَاتُ وَالتَّعْلِيلُ</a:t>
@@ -43575,6 +43695,7 @@
                   <a:srgbClr val="9AA1AB"/>
                 </a:solidFill>
                 <a:latin typeface="Amiri" pitchFamily="2" charset="-78"/>
+                <a:ea typeface="Amiri" pitchFamily="2" charset="-78"/>
                 <a:cs typeface="Amiri" pitchFamily="2" charset="-78"/>
               </a:rPr>
               <a:t>هِيَ وَدُودٌ وَصَادِقٌ.</a:t>
@@ -43703,6 +43824,7 @@
                   <a:srgbClr val="1F2A37"/>
                 </a:solidFill>
                 <a:latin typeface="Amiri" pitchFamily="2" charset="-78"/>
+                <a:ea typeface="Amiri" pitchFamily="2" charset="-78"/>
                 <a:cs typeface="Amiri" pitchFamily="2" charset="-78"/>
               </a:rPr>
               <a:t>هِيَ وَدُودَةٌ وَصَادِقَةٌ.</a:t>
@@ -43804,6 +43926,7 @@
                   <a:srgbClr val="9AA1AB"/>
                 </a:solidFill>
                 <a:latin typeface="Amiri" pitchFamily="2" charset="-78"/>
+                <a:ea typeface="Amiri" pitchFamily="2" charset="-78"/>
                 <a:cs typeface="Amiri" pitchFamily="2" charset="-78"/>
               </a:rPr>
               <a:t>هُوَ وَدُودَةٌ.</a:t>
@@ -44105,6 +44228,7 @@
                   <a:srgbClr val="1F2A37"/>
                 </a:solidFill>
                 <a:latin typeface="Amiri" pitchFamily="2" charset="-78"/>
+                <a:ea typeface="Amiri" pitchFamily="2" charset="-78"/>
                 <a:cs typeface="Amiri" pitchFamily="2" charset="-78"/>
               </a:rPr>
               <a:t>أَحْتَرِمُهَا.</a:t>
@@ -44206,6 +44330,7 @@
                   <a:srgbClr val="9AA1AB"/>
                 </a:solidFill>
                 <a:latin typeface="Amiri" pitchFamily="2" charset="-78"/>
+                <a:ea typeface="Amiri" pitchFamily="2" charset="-78"/>
                 <a:cs typeface="Amiri" pitchFamily="2" charset="-78"/>
               </a:rPr>
               <a:t>أَحْتَرِمُهُ.</a:t>
@@ -44307,6 +44432,7 @@
                   <a:srgbClr val="9AA1AB"/>
                 </a:solidFill>
                 <a:latin typeface="Amiri" pitchFamily="2" charset="-78"/>
+                <a:ea typeface="Amiri" pitchFamily="2" charset="-78"/>
                 <a:cs typeface="Amiri" pitchFamily="2" charset="-78"/>
               </a:rPr>
               <a:t>تَحْتَرِمُنِي.</a:t>
@@ -44345,6 +44471,7 @@
                   <a:srgbClr val="8A6D1E"/>
                 </a:solidFill>
                 <a:latin typeface="Amiri" pitchFamily="2" charset="-78"/>
+                <a:ea typeface="Amiri" pitchFamily="2" charset="-78"/>
                 <a:cs typeface="Amiri" pitchFamily="2" charset="-78"/>
               </a:rPr>
               <a:t>ـها</a:t>
@@ -44594,6 +44721,7 @@
                   <a:srgbClr val="9AA1AB"/>
                 </a:solidFill>
                 <a:latin typeface="Amiri" pitchFamily="2" charset="-78"/>
+                <a:ea typeface="Amiri" pitchFamily="2" charset="-78"/>
                 <a:cs typeface="Amiri" pitchFamily="2" charset="-78"/>
               </a:rPr>
               <a:t>هٰذَا السُّتْرَةُ</a:t>
@@ -44695,6 +44823,7 @@
                   <a:srgbClr val="9AA1AB"/>
                 </a:solidFill>
                 <a:latin typeface="Amiri" pitchFamily="2" charset="-78"/>
+                <a:ea typeface="Amiri" pitchFamily="2" charset="-78"/>
                 <a:cs typeface="Amiri" pitchFamily="2" charset="-78"/>
               </a:rPr>
               <a:t>هٰذِهِ السُّتْرَةَ</a:t>
@@ -44823,6 +44952,7 @@
                   <a:srgbClr val="1F2A37"/>
                 </a:solidFill>
                 <a:latin typeface="Amiri" pitchFamily="2" charset="-78"/>
+                <a:ea typeface="Amiri" pitchFamily="2" charset="-78"/>
                 <a:cs typeface="Amiri" pitchFamily="2" charset="-78"/>
               </a:rPr>
               <a:t>هٰذِهِ السُّتْرَةُ</a:t>
@@ -44861,6 +44991,7 @@
                   <a:srgbClr val="8A6D1E"/>
                 </a:solidFill>
                 <a:latin typeface="Amiri" pitchFamily="2" charset="-78"/>
+                <a:ea typeface="Amiri" pitchFamily="2" charset="-78"/>
                 <a:cs typeface="Amiri" pitchFamily="2" charset="-78"/>
               </a:rPr>
               <a:t>سُتْرَةٌ</a:t>
@@ -45110,6 +45241,7 @@
                   <a:srgbClr val="9AA1AB"/>
                 </a:solidFill>
                 <a:latin typeface="Amiri" pitchFamily="2" charset="-78"/>
+                <a:ea typeface="Amiri" pitchFamily="2" charset="-78"/>
                 <a:cs typeface="Amiri" pitchFamily="2" charset="-78"/>
               </a:rPr>
               <a:t>الفَتَاةُ الَّذِي يَرْتَدِي</a:t>
@@ -45211,6 +45343,7 @@
                   <a:srgbClr val="9AA1AB"/>
                 </a:solidFill>
                 <a:latin typeface="Amiri" pitchFamily="2" charset="-78"/>
+                <a:ea typeface="Amiri" pitchFamily="2" charset="-78"/>
                 <a:cs typeface="Amiri" pitchFamily="2" charset="-78"/>
               </a:rPr>
               <a:t>الوَلَدُ الَّتِي تَرْتَدِي</a:t>
@@ -45339,6 +45472,7 @@
                   <a:srgbClr val="1F2A37"/>
                 </a:solidFill>
                 <a:latin typeface="Amiri" pitchFamily="2" charset="-78"/>
+                <a:ea typeface="Amiri" pitchFamily="2" charset="-78"/>
                 <a:cs typeface="Amiri" pitchFamily="2" charset="-78"/>
               </a:rPr>
               <a:t>الفَتَاةُ الَّتِي تَرْتَدِي نَظَّارَةً</a:t>
@@ -45390,6 +45524,7 @@
                   <a:srgbClr val="8A6D1E"/>
                 </a:solidFill>
                 <a:latin typeface="Amiri" pitchFamily="2" charset="-78"/>
+                <a:ea typeface="Amiri" pitchFamily="2" charset="-78"/>
                 <a:cs typeface="Amiri" pitchFamily="2" charset="-78"/>
               </a:rPr>
               <a:t>التي</a:t>
@@ -45666,6 +45801,7 @@
                   <a:srgbClr val="1F2A37"/>
                 </a:solidFill>
                 <a:latin typeface="Amiri" pitchFamily="2" charset="-78"/>
+                <a:ea typeface="Amiri" pitchFamily="2" charset="-78"/>
                 <a:cs typeface="Amiri" pitchFamily="2" charset="-78"/>
               </a:rPr>
               <a:t>عَيْنَاهَا بُنِّيَّتَانِ.</a:t>
@@ -45767,6 +45903,7 @@
                   <a:srgbClr val="9AA1AB"/>
                 </a:solidFill>
                 <a:latin typeface="Amiri" pitchFamily="2" charset="-78"/>
+                <a:ea typeface="Amiri" pitchFamily="2" charset="-78"/>
                 <a:cs typeface="Amiri" pitchFamily="2" charset="-78"/>
               </a:rPr>
               <a:t>عَيْنَاهَا بُنِّيَّةٌ.</a:t>
@@ -45868,6 +46005,7 @@
                   <a:srgbClr val="9AA1AB"/>
                 </a:solidFill>
                 <a:latin typeface="Amiri" pitchFamily="2" charset="-78"/>
+                <a:ea typeface="Amiri" pitchFamily="2" charset="-78"/>
                 <a:cs typeface="Amiri" pitchFamily="2" charset="-78"/>
               </a:rPr>
               <a:t>عَيْنَاهَا بُنِّيٌّ.</a:t>
@@ -45919,6 +46057,7 @@
                   <a:srgbClr val="8A6D1E"/>
                 </a:solidFill>
                 <a:latin typeface="Amiri" pitchFamily="2" charset="-78"/>
+                <a:ea typeface="Amiri" pitchFamily="2" charset="-78"/>
                 <a:cs typeface="Amiri" pitchFamily="2" charset="-78"/>
               </a:rPr>
               <a:t>بُنِّيَّتَانِ</a:t>
@@ -46080,6 +46219,7 @@
                   <a:srgbClr val="1B3B6F"/>
                 </a:solidFill>
                 <a:latin typeface="Amiri" pitchFamily="2" charset="-78"/>
+                <a:ea typeface="Amiri" pitchFamily="2" charset="-78"/>
                 <a:cs typeface="Amiri" pitchFamily="2" charset="-78"/>
               </a:rPr>
               <a:t>مُرَاجَعَةٌ ثُمَّ تَقْيِيمٌ</a:t>
@@ -46213,6 +46353,7 @@
                   <a:srgbClr val="D4AF37"/>
                 </a:solidFill>
                 <a:latin typeface="Amiri" pitchFamily="2" charset="-78"/>
+                <a:ea typeface="Amiri" pitchFamily="2" charset="-78"/>
                 <a:cs typeface="Amiri" pitchFamily="2" charset="-78"/>
               </a:rPr>
               <a:t>م</a:t>
@@ -46598,6 +46739,7 @@
                   <a:srgbClr val="8A6D1E"/>
                 </a:solidFill>
                 <a:latin typeface="Amiri" pitchFamily="2" charset="-78"/>
+                <a:ea typeface="Amiri" pitchFamily="2" charset="-78"/>
                 <a:cs typeface="Amiri" pitchFamily="2" charset="-78"/>
               </a:rPr>
               <a:t>مُخْتَبَرُ القَوَاعِدِ</a:t>
@@ -46809,6 +46951,7 @@
                   <a:srgbClr val="1F2A37"/>
                 </a:solidFill>
                 <a:latin typeface="Amiri" pitchFamily="2" charset="-78"/>
+                <a:ea typeface="Amiri" pitchFamily="2" charset="-78"/>
                 <a:cs typeface="Amiri" pitchFamily="2" charset="-78"/>
               </a:rPr>
               <a:t>هٰذَا أَرْخَصُ ___ ذٰلِكَ.</a:t>
@@ -46910,6 +47053,7 @@
                   <a:srgbClr val="1F2A37"/>
                 </a:solidFill>
                 <a:latin typeface="Amiri" pitchFamily="2" charset="-78"/>
+                <a:ea typeface="Amiri" pitchFamily="2" charset="-78"/>
                 <a:cs typeface="Amiri" pitchFamily="2" charset="-78"/>
               </a:rPr>
               <a:t>مَعَ</a:t>
@@ -47011,6 +47155,7 @@
                   <a:srgbClr val="1F2A37"/>
                 </a:solidFill>
                 <a:latin typeface="Amiri" pitchFamily="2" charset="-78"/>
+                <a:ea typeface="Amiri" pitchFamily="2" charset="-78"/>
                 <a:cs typeface="Amiri" pitchFamily="2" charset="-78"/>
               </a:rPr>
               <a:t>مِنْ</a:t>
@@ -47112,6 +47257,7 @@
                   <a:srgbClr val="1F2A37"/>
                 </a:solidFill>
                 <a:latin typeface="Amiri" pitchFamily="2" charset="-78"/>
+                <a:ea typeface="Amiri" pitchFamily="2" charset="-78"/>
                 <a:cs typeface="Amiri" pitchFamily="2" charset="-78"/>
               </a:rPr>
               <a:t>عَلَى</a:t>
@@ -47348,6 +47494,7 @@
                   <a:srgbClr val="1F2A37"/>
                 </a:solidFill>
                 <a:latin typeface="Amiri" pitchFamily="2" charset="-78"/>
+                <a:ea typeface="Amiri" pitchFamily="2" charset="-78"/>
                 <a:cs typeface="Amiri" pitchFamily="2" charset="-78"/>
               </a:rPr>
               <a:t>هِيَ مُتَعَاوِنَةٌ لِأَنَّهَا تُسَاعِدُ زَمِيلَاتِهَا.</a:t>
@@ -47449,6 +47596,7 @@
                   <a:srgbClr val="1F2A37"/>
                 </a:solidFill>
                 <a:latin typeface="Amiri" pitchFamily="2" charset="-78"/>
+                <a:ea typeface="Amiri" pitchFamily="2" charset="-78"/>
                 <a:cs typeface="Amiri" pitchFamily="2" charset="-78"/>
               </a:rPr>
               <a:t>هِيَ مُتَعَاوِنَةٌ لِأَنَّ قَمِيصَهَا أَزْرَقُ.</a:t>
@@ -47550,6 +47698,7 @@
                   <a:srgbClr val="1F2A37"/>
                 </a:solidFill>
                 <a:latin typeface="Amiri" pitchFamily="2" charset="-78"/>
+                <a:ea typeface="Amiri" pitchFamily="2" charset="-78"/>
                 <a:cs typeface="Amiri" pitchFamily="2" charset="-78"/>
               </a:rPr>
               <a:t>هِيَ مُتَعَاوِنَةٌ.</a:t>
@@ -47786,6 +47935,7 @@
                   <a:srgbClr val="1F2A37"/>
                 </a:solidFill>
                 <a:latin typeface="Amiri" pitchFamily="2" charset="-78"/>
+                <a:ea typeface="Amiri" pitchFamily="2" charset="-78"/>
                 <a:cs typeface="Amiri" pitchFamily="2" charset="-78"/>
               </a:rPr>
               <a:t>أُحِبُّ المَوْضَةَ لِأَنَّ.</a:t>
@@ -47887,6 +48037,7 @@
                   <a:srgbClr val="1F2A37"/>
                 </a:solidFill>
                 <a:latin typeface="Amiri" pitchFamily="2" charset="-78"/>
+                <a:ea typeface="Amiri" pitchFamily="2" charset="-78"/>
                 <a:cs typeface="Amiri" pitchFamily="2" charset="-78"/>
               </a:rPr>
               <a:t>المَوْضَةُ دَائِمًا صَحِيحَةٌ.</a:t>
@@ -47988,6 +48139,7 @@
                   <a:srgbClr val="1F2A37"/>
                 </a:solidFill>
                 <a:latin typeface="Amiri" pitchFamily="2" charset="-78"/>
+                <a:ea typeface="Amiri" pitchFamily="2" charset="-78"/>
                 <a:cs typeface="Amiri" pitchFamily="2" charset="-78"/>
               </a:rPr>
               <a:t>أُحِبُّ المَوْضَةَ، وَلٰكِنَّنِي أَخْتَارُ مَا يُنَاسِبُنِي.</a:t>
@@ -48224,6 +48376,7 @@
                   <a:srgbClr val="1F2A37"/>
                 </a:solidFill>
                 <a:latin typeface="Amiri" pitchFamily="2" charset="-78"/>
+                <a:ea typeface="Amiri" pitchFamily="2" charset="-78"/>
                 <a:cs typeface="Amiri" pitchFamily="2" charset="-78"/>
               </a:rPr>
               <a:t>هٰذَا أَفْضَلُ مِنْ ذٰلِكَ.</a:t>
@@ -48325,6 +48478,7 @@
                   <a:srgbClr val="1F2A37"/>
                 </a:solidFill>
                 <a:latin typeface="Amiri" pitchFamily="2" charset="-78"/>
+                <a:ea typeface="Amiri" pitchFamily="2" charset="-78"/>
                 <a:cs typeface="Amiri" pitchFamily="2" charset="-78"/>
               </a:rPr>
               <a:t>هٰذَا جَيِّدٌ.</a:t>
@@ -48426,6 +48580,7 @@
                   <a:srgbClr val="1F2A37"/>
                 </a:solidFill>
                 <a:latin typeface="Amiri" pitchFamily="2" charset="-78"/>
+                <a:ea typeface="Amiri" pitchFamily="2" charset="-78"/>
                 <a:cs typeface="Amiri" pitchFamily="2" charset="-78"/>
               </a:rPr>
               <a:t>هٰذَا الخِيَارُ الأَفْضَلُ.</a:t>
@@ -48599,6 +48754,7 @@
                   <a:srgbClr val="1F2A37"/>
                 </a:solidFill>
                 <a:latin typeface="Amiri" pitchFamily="2" charset="-78"/>
+                <a:ea typeface="Amiri" pitchFamily="2" charset="-78"/>
                 <a:cs typeface="Amiri" pitchFamily="2" charset="-78"/>
               </a:rPr>
               <a:t>عَلَاقَتُنَا قَوِيَّةٌ ___ نَثِقُ بِبَعْضِنَا.</a:t>
@@ -48700,6 +48856,7 @@
                   <a:srgbClr val="1F2A37"/>
                 </a:solidFill>
                 <a:latin typeface="Amiri" pitchFamily="2" charset="-78"/>
+                <a:ea typeface="Amiri" pitchFamily="2" charset="-78"/>
                 <a:cs typeface="Amiri" pitchFamily="2" charset="-78"/>
               </a:rPr>
               <a:t>لِأَنَّنَا</a:t>
@@ -48801,6 +48958,7 @@
                   <a:srgbClr val="1F2A37"/>
                 </a:solidFill>
                 <a:latin typeface="Amiri" pitchFamily="2" charset="-78"/>
+                <a:ea typeface="Amiri" pitchFamily="2" charset="-78"/>
                 <a:cs typeface="Amiri" pitchFamily="2" charset="-78"/>
               </a:rPr>
               <a:t>لِأَنَّهُ</a:t>
@@ -48902,6 +49060,7 @@
                   <a:srgbClr val="1F2A37"/>
                 </a:solidFill>
                 <a:latin typeface="Amiri" pitchFamily="2" charset="-78"/>
+                <a:ea typeface="Amiri" pitchFamily="2" charset="-78"/>
                 <a:cs typeface="Amiri" pitchFamily="2" charset="-78"/>
               </a:rPr>
               <a:t>وَلٰكِنَّهَا</a:t>
@@ -49138,6 +49297,7 @@
                   <a:srgbClr val="1F2A37"/>
                 </a:solidFill>
                 <a:latin typeface="Amiri" pitchFamily="2" charset="-78"/>
+                <a:ea typeface="Amiri" pitchFamily="2" charset="-78"/>
                 <a:cs typeface="Amiri" pitchFamily="2" charset="-78"/>
               </a:rPr>
               <a:t>هٰذَا المِعْطَفُ.</a:t>
@@ -49239,6 +49399,7 @@
                   <a:srgbClr val="1F2A37"/>
                 </a:solidFill>
                 <a:latin typeface="Amiri" pitchFamily="2" charset="-78"/>
+                <a:ea typeface="Amiri" pitchFamily="2" charset="-78"/>
                 <a:cs typeface="Amiri" pitchFamily="2" charset="-78"/>
               </a:rPr>
               <a:t>أُفَضِّلُ هٰذَا المِعْطَفَ لِأَنَّهُ أَرْخَصُ وَأَكْثَرُ رَاحَةً.</a:t>
@@ -49340,6 +49501,7 @@
                   <a:srgbClr val="1F2A37"/>
                 </a:solidFill>
                 <a:latin typeface="Amiri" pitchFamily="2" charset="-78"/>
+                <a:ea typeface="Amiri" pitchFamily="2" charset="-78"/>
                 <a:cs typeface="Amiri" pitchFamily="2" charset="-78"/>
               </a:rPr>
               <a:t>نَعَمْ.</a:t>
@@ -49473,6 +49635,7 @@
                   <a:srgbClr val="D4AF37"/>
                 </a:solidFill>
                 <a:latin typeface="Amiri" pitchFamily="2" charset="-78"/>
+                <a:ea typeface="Amiri" pitchFamily="2" charset="-78"/>
                 <a:cs typeface="Amiri" pitchFamily="2" charset="-78"/>
               </a:rPr>
               <a:t>م</a:t>
@@ -49858,6 +50021,7 @@
                   <a:srgbClr val="8A6D1E"/>
                 </a:solidFill>
                 <a:latin typeface="Amiri" pitchFamily="2" charset="-78"/>
+                <a:ea typeface="Amiri" pitchFamily="2" charset="-78"/>
                 <a:cs typeface="Amiri" pitchFamily="2" charset="-78"/>
               </a:rPr>
               <a:t>الإِجَابَاتُ</a:t>
@@ -50069,6 +50233,7 @@
                   <a:srgbClr val="1F2A37"/>
                 </a:solidFill>
                 <a:latin typeface="Amiri" pitchFamily="2" charset="-78"/>
+                <a:ea typeface="Amiri" pitchFamily="2" charset="-78"/>
                 <a:cs typeface="Amiri" pitchFamily="2" charset="-78"/>
               </a:rPr>
               <a:t>هٰذَا أَرْخَصُ ___ ذٰلِكَ.</a:t>
@@ -50170,6 +50335,7 @@
                   <a:srgbClr val="9AA1AB"/>
                 </a:solidFill>
                 <a:latin typeface="Amiri" pitchFamily="2" charset="-78"/>
+                <a:ea typeface="Amiri" pitchFamily="2" charset="-78"/>
                 <a:cs typeface="Amiri" pitchFamily="2" charset="-78"/>
               </a:rPr>
               <a:t>مَعَ</a:t>
@@ -50298,6 +50464,7 @@
                   <a:srgbClr val="1F2A37"/>
                 </a:solidFill>
                 <a:latin typeface="Amiri" pitchFamily="2" charset="-78"/>
+                <a:ea typeface="Amiri" pitchFamily="2" charset="-78"/>
                 <a:cs typeface="Amiri" pitchFamily="2" charset="-78"/>
               </a:rPr>
               <a:t>مِنْ</a:t>
@@ -50399,6 +50566,7 @@
                   <a:srgbClr val="9AA1AB"/>
                 </a:solidFill>
                 <a:latin typeface="Amiri" pitchFamily="2" charset="-78"/>
+                <a:ea typeface="Amiri" pitchFamily="2" charset="-78"/>
                 <a:cs typeface="Amiri" pitchFamily="2" charset="-78"/>
               </a:rPr>
               <a:t>عَلَى</a:t>
@@ -50450,6 +50618,7 @@
                   <a:srgbClr val="8A6D1E"/>
                 </a:solidFill>
                 <a:latin typeface="Amiri" pitchFamily="2" charset="-78"/>
+                <a:ea typeface="Amiri" pitchFamily="2" charset="-78"/>
                 <a:cs typeface="Amiri" pitchFamily="2" charset="-78"/>
               </a:rPr>
               <a:t>مِنْ</a:t>
@@ -50726,6 +50895,7 @@
                   <a:srgbClr val="1F2A37"/>
                 </a:solidFill>
                 <a:latin typeface="Amiri" pitchFamily="2" charset="-78"/>
+                <a:ea typeface="Amiri" pitchFamily="2" charset="-78"/>
                 <a:cs typeface="Amiri" pitchFamily="2" charset="-78"/>
               </a:rPr>
               <a:t>هِيَ مُتَعَاوِنَةٌ لِأَنَّهَا تُسَاعِدُ زَمِيلَاتِهَا.</a:t>
@@ -50827,6 +50997,7 @@
                   <a:srgbClr val="9AA1AB"/>
                 </a:solidFill>
                 <a:latin typeface="Amiri" pitchFamily="2" charset="-78"/>
+                <a:ea typeface="Amiri" pitchFamily="2" charset="-78"/>
                 <a:cs typeface="Amiri" pitchFamily="2" charset="-78"/>
               </a:rPr>
               <a:t>هِيَ مُتَعَاوِنَةٌ لِأَنَّ قَمِيصَهَا أَزْرَقُ.</a:t>
@@ -50928,6 +51099,7 @@
                   <a:srgbClr val="9AA1AB"/>
                 </a:solidFill>
                 <a:latin typeface="Amiri" pitchFamily="2" charset="-78"/>
+                <a:ea typeface="Amiri" pitchFamily="2" charset="-78"/>
                 <a:cs typeface="Amiri" pitchFamily="2" charset="-78"/>
               </a:rPr>
               <a:t>هِيَ مُتَعَاوِنَةٌ.</a:t>
@@ -51202,6 +51374,7 @@
                   <a:srgbClr val="9AA1AB"/>
                 </a:solidFill>
                 <a:latin typeface="Amiri" pitchFamily="2" charset="-78"/>
+                <a:ea typeface="Amiri" pitchFamily="2" charset="-78"/>
                 <a:cs typeface="Amiri" pitchFamily="2" charset="-78"/>
               </a:rPr>
               <a:t>أُحِبُّ المَوْضَةَ لِأَنَّ.</a:t>
@@ -51303,6 +51476,7 @@
                   <a:srgbClr val="9AA1AB"/>
                 </a:solidFill>
                 <a:latin typeface="Amiri" pitchFamily="2" charset="-78"/>
+                <a:ea typeface="Amiri" pitchFamily="2" charset="-78"/>
                 <a:cs typeface="Amiri" pitchFamily="2" charset="-78"/>
               </a:rPr>
               <a:t>المَوْضَةُ دَائِمًا صَحِيحَةٌ.</a:t>
@@ -51431,6 +51605,7 @@
                   <a:srgbClr val="1F2A37"/>
                 </a:solidFill>
                 <a:latin typeface="Amiri" pitchFamily="2" charset="-78"/>
+                <a:ea typeface="Amiri" pitchFamily="2" charset="-78"/>
                 <a:cs typeface="Amiri" pitchFamily="2" charset="-78"/>
               </a:rPr>
               <a:t>أُحِبُّ المَوْضَةَ، وَلٰكِنَّنِي أَخْتَارُ مَا يُنَاسِبُنِي.</a:t>
@@ -51705,6 +51880,7 @@
                   <a:srgbClr val="9AA1AB"/>
                 </a:solidFill>
                 <a:latin typeface="Amiri" pitchFamily="2" charset="-78"/>
+                <a:ea typeface="Amiri" pitchFamily="2" charset="-78"/>
                 <a:cs typeface="Amiri" pitchFamily="2" charset="-78"/>
               </a:rPr>
               <a:t>هٰذَا أَفْضَلُ مِنْ ذٰلِكَ.</a:t>
@@ -51806,6 +51982,7 @@
                   <a:srgbClr val="9AA1AB"/>
                 </a:solidFill>
                 <a:latin typeface="Amiri" pitchFamily="2" charset="-78"/>
+                <a:ea typeface="Amiri" pitchFamily="2" charset="-78"/>
                 <a:cs typeface="Amiri" pitchFamily="2" charset="-78"/>
               </a:rPr>
               <a:t>هٰذَا جَيِّدٌ.</a:t>
@@ -51934,6 +52111,7 @@
                   <a:srgbClr val="1F2A37"/>
                 </a:solidFill>
                 <a:latin typeface="Amiri" pitchFamily="2" charset="-78"/>
+                <a:ea typeface="Amiri" pitchFamily="2" charset="-78"/>
                 <a:cs typeface="Amiri" pitchFamily="2" charset="-78"/>
               </a:rPr>
               <a:t>هٰذَا الخِيَارُ الأَفْضَلُ.</a:t>
@@ -51985,6 +52163,7 @@
                   <a:srgbClr val="8A6D1E"/>
                 </a:solidFill>
                 <a:latin typeface="Amiri" pitchFamily="2" charset="-78"/>
+                <a:ea typeface="Amiri" pitchFamily="2" charset="-78"/>
                 <a:cs typeface="Amiri" pitchFamily="2" charset="-78"/>
               </a:rPr>
               <a:t>الأَفْضَلُ</a:t>
@@ -52171,6 +52350,7 @@
                   <a:srgbClr val="1F2A37"/>
                 </a:solidFill>
                 <a:latin typeface="Amiri" pitchFamily="2" charset="-78"/>
+                <a:ea typeface="Amiri" pitchFamily="2" charset="-78"/>
                 <a:cs typeface="Amiri" pitchFamily="2" charset="-78"/>
               </a:rPr>
               <a:t>عَلَاقَتُنَا قَوِيَّةٌ ___ نَثِقُ بِبَعْضِنَا.</a:t>
@@ -52299,6 +52479,7 @@
                   <a:srgbClr val="1F2A37"/>
                 </a:solidFill>
                 <a:latin typeface="Amiri" pitchFamily="2" charset="-78"/>
+                <a:ea typeface="Amiri" pitchFamily="2" charset="-78"/>
                 <a:cs typeface="Amiri" pitchFamily="2" charset="-78"/>
               </a:rPr>
               <a:t>لِأَنَّنَا</a:t>
@@ -52400,6 +52581,7 @@
                   <a:srgbClr val="9AA1AB"/>
                 </a:solidFill>
                 <a:latin typeface="Amiri" pitchFamily="2" charset="-78"/>
+                <a:ea typeface="Amiri" pitchFamily="2" charset="-78"/>
                 <a:cs typeface="Amiri" pitchFamily="2" charset="-78"/>
               </a:rPr>
               <a:t>لِأَنَّهُ</a:t>
@@ -52501,6 +52683,7 @@
                   <a:srgbClr val="9AA1AB"/>
                 </a:solidFill>
                 <a:latin typeface="Amiri" pitchFamily="2" charset="-78"/>
+                <a:ea typeface="Amiri" pitchFamily="2" charset="-78"/>
                 <a:cs typeface="Amiri" pitchFamily="2" charset="-78"/>
               </a:rPr>
               <a:t>وَلٰكِنَّهَا</a:t>
@@ -52552,6 +52735,7 @@
                   <a:srgbClr val="8A6D1E"/>
                 </a:solidFill>
                 <a:latin typeface="Amiri" pitchFamily="2" charset="-78"/>
+                <a:ea typeface="Amiri" pitchFamily="2" charset="-78"/>
                 <a:cs typeface="Amiri" pitchFamily="2" charset="-78"/>
               </a:rPr>
               <a:t>لِأَنَّنَا</a:t>
@@ -52801,6 +52985,7 @@
                   <a:srgbClr val="9AA1AB"/>
                 </a:solidFill>
                 <a:latin typeface="Amiri" pitchFamily="2" charset="-78"/>
+                <a:ea typeface="Amiri" pitchFamily="2" charset="-78"/>
                 <a:cs typeface="Amiri" pitchFamily="2" charset="-78"/>
               </a:rPr>
               <a:t>هٰذَا المِعْطَفُ.</a:t>
@@ -52929,6 +53114,7 @@
                   <a:srgbClr val="1F2A37"/>
                 </a:solidFill>
                 <a:latin typeface="Amiri" pitchFamily="2" charset="-78"/>
+                <a:ea typeface="Amiri" pitchFamily="2" charset="-78"/>
                 <a:cs typeface="Amiri" pitchFamily="2" charset="-78"/>
               </a:rPr>
               <a:t>أُفَضِّلُ هٰذَا المِعْطَفَ لِأَنَّهُ أَرْخَصُ وَأَكْثَرُ رَاحَةً.</a:t>
@@ -53030,6 +53216,7 @@
                   <a:srgbClr val="9AA1AB"/>
                 </a:solidFill>
                 <a:latin typeface="Amiri" pitchFamily="2" charset="-78"/>
+                <a:ea typeface="Amiri" pitchFamily="2" charset="-78"/>
                 <a:cs typeface="Amiri" pitchFamily="2" charset="-78"/>
               </a:rPr>
               <a:t>نَعَمْ.</a:t>
@@ -53201,6 +53388,7 @@
                   <a:srgbClr val="D4AF37"/>
                 </a:solidFill>
                 <a:latin typeface="Amiri" pitchFamily="2" charset="-78"/>
+                <a:ea typeface="Amiri" pitchFamily="2" charset="-78"/>
                 <a:cs typeface="Amiri" pitchFamily="2" charset="-78"/>
               </a:rPr>
               <a:t>م</a:t>
@@ -53521,6 +53709,7 @@
                   <a:srgbClr val="8A6D1E"/>
                 </a:solidFill>
                 <a:latin typeface="Amiri" pitchFamily="2" charset="-78"/>
+                <a:ea typeface="Amiri" pitchFamily="2" charset="-78"/>
                 <a:cs typeface="Amiri" pitchFamily="2" charset="-78"/>
               </a:rPr>
               <a:t>خُطَّةُ التَّقْيِيمِ</a:t>
@@ -53852,6 +54041,7 @@
                   <a:srgbClr val="5A6472"/>
                 </a:solidFill>
                 <a:latin typeface="Amiri" pitchFamily="2" charset="-78"/>
+                <a:ea typeface="Amiri" pitchFamily="2" charset="-78"/>
                 <a:cs typeface="Amiri" pitchFamily="2" charset="-78"/>
               </a:rPr>
               <a:t>الاِسْتِمَاعُ</a:t>
@@ -54071,6 +54261,7 @@
                   <a:srgbClr val="5A6472"/>
                 </a:solidFill>
                 <a:latin typeface="Amiri" pitchFamily="2" charset="-78"/>
+                <a:ea typeface="Amiri" pitchFamily="2" charset="-78"/>
                 <a:cs typeface="Amiri" pitchFamily="2" charset="-78"/>
               </a:rPr>
               <a:t>القِرَاءَةُ</a:t>
@@ -54290,6 +54481,7 @@
                   <a:srgbClr val="5A6472"/>
                 </a:solidFill>
                 <a:latin typeface="Amiri" pitchFamily="2" charset="-78"/>
+                <a:ea typeface="Amiri" pitchFamily="2" charset="-78"/>
                 <a:cs typeface="Amiri" pitchFamily="2" charset="-78"/>
               </a:rPr>
               <a:t>الكِتَابَةُ</a:t>
@@ -54509,6 +54701,7 @@
                   <a:srgbClr val="5A6472"/>
                 </a:solidFill>
                 <a:latin typeface="Amiri" pitchFamily="2" charset="-78"/>
+                <a:ea typeface="Amiri" pitchFamily="2" charset="-78"/>
                 <a:cs typeface="Amiri" pitchFamily="2" charset="-78"/>
               </a:rPr>
               <a:t>التَّحَدُّثُ</a:t>
@@ -54707,6 +54900,7 @@
                   <a:srgbClr val="D4AF37"/>
                 </a:solidFill>
                 <a:latin typeface="Amiri" pitchFamily="2" charset="-78"/>
+                <a:ea typeface="Amiri" pitchFamily="2" charset="-78"/>
                 <a:cs typeface="Amiri" pitchFamily="2" charset="-78"/>
               </a:rPr>
               <a:t>م</a:t>
@@ -55027,6 +55221,7 @@
                   <a:srgbClr val="8A6D1E"/>
                 </a:solidFill>
                 <a:latin typeface="Amiri" pitchFamily="2" charset="-78"/>
+                <a:ea typeface="Amiri" pitchFamily="2" charset="-78"/>
                 <a:cs typeface="Amiri" pitchFamily="2" charset="-78"/>
               </a:rPr>
               <a:t>الاِسْتِمَاعُ (١)</a:t>
@@ -57917,13 +58112,9 @@
     <a:fontScheme name="Office">
       <a:majorFont>
         <a:latin typeface="Calibri Light" panose="020F0302020204030204"/>
-        <a:ea typeface=""/>
-        <a:cs typeface=""/>
-        <a:font script="Jpan" typeface="游ゴシック Light"/>
-        <a:font script="Hang" typeface="맑은 고딕"/>
-        <a:font script="Hans" typeface="等线 Light"/>
-        <a:font script="Hant" typeface="新細明體"/>
-        <a:font script="Arab" typeface="Times New Roman"/>
+        <a:ea typeface="Amiri" pitchFamily="2" charset="-78"/>
+        <a:cs typeface="Amiri" pitchFamily="2" charset="-78"/>
+        <a:font script="Arab" typeface="Amiri"/>
         <a:font script="Hebr" typeface="Times New Roman"/>
         <a:font script="Thai" typeface="Angsana New"/>
         <a:font script="Ethi" typeface="Nyala"/>
@@ -57969,13 +58160,9 @@
       </a:majorFont>
       <a:minorFont>
         <a:latin typeface="Calibri" panose="020F0502020204030204"/>
-        <a:ea typeface=""/>
-        <a:cs typeface=""/>
-        <a:font script="Jpan" typeface="游ゴシック"/>
-        <a:font script="Hang" typeface="맑은 고딕"/>
-        <a:font script="Hans" typeface="等线"/>
-        <a:font script="Hant" typeface="新細明體"/>
-        <a:font script="Arab" typeface="Arial"/>
+        <a:ea typeface="Amiri" pitchFamily="2" charset="-78"/>
+        <a:cs typeface="Amiri" pitchFamily="2" charset="-78"/>
+        <a:font script="Arab" typeface="Amiri"/>
         <a:font script="Hebr" typeface="Arial"/>
         <a:font script="Thai" typeface="Cordia New"/>
         <a:font script="Ethi" typeface="Nyala"/>

</xml_diff>